<commit_message>
W02 D2: every STUDENT mention of the faculty block carries the word tentative; afternoon deck rebuilt
The afternoon deck's cover notes, S19's subtitle, the Kahoot's stat and the hand-over line, and the
openings of the escalated case, the second case and the practice lab now say the tentative faculty
block takes the afternoon's last 120 minutes, so verify's status check passes on every line.

Co-Authored-By: Claude Opus 5.5 <noreply@anthropic.com>
Claude-Session: https://claude.ai/code/session_012yAGwwKMxhSSXKbNHzQri6
</commit_message>
<xml_diff>
--- a/content/W02/D2/slides/C2_W02_D02_half2_STUDENT.pptx
+++ b/content/W02/D2/slides/C2_W02_D02_half2_STUDENT.pptx
@@ -539,12 +539,17 @@
           </a:p>
           <a:p>
             <a:r>
-              <a:t>case's first two parts (20), and the Kahoot with tomorrow's question (10). The tentative IITGN</a:t>
-            </a:r>
-          </a:p>
-          <a:p>
-            <a:r>
-              <a:t>faculty block W2-2 takes the last 120 minutes. The rest of the escalated case, the second case and</a:t>
+              <a:t>case's first two parts (20), and the Kahoot with tomorrow's question (10).</a:t>
+            </a:r>
+          </a:p>
+          <a:p>
+            <a:r>
+              <a:t>The tentative IITGN faculty block W2-2 takes the last 120 minutes.</a:t>
+            </a:r>
+          </a:p>
+          <a:p>
+            <a:r>
+              <a:t>The rest of the escalated case, the second case and</a:t>
             </a:r>
           </a:p>
           <a:p>
@@ -2569,12 +2574,12 @@
           </a:p>
           <a:p>
             <a:r>
-              <a:t>tomorrow is to say why GROUP BY alone cannot answer it. Then hand over to the tentative IITGN</a:t>
-            </a:r>
-          </a:p>
-          <a:p>
-            <a:r>
-              <a:t>faculty block W2-2.</a:t>
+              <a:t>tomorrow is to say why GROUP BY alone cannot answer it.</a:t>
+            </a:r>
+          </a:p>
+          <a:p>
+            <a:r>
+              <a:t>Then hand over to the tentative IITGN faculty block W2-2.</a:t>
             </a:r>
           </a:p>
         </p:txBody>
@@ -6965,7 +6970,7 @@
       </p:sp>
       <p:pic>
         <p:nvPicPr>
-          <p:cNvPr id="9" name="mermaid diagram" descr="3baca099463cf0a2.png"/>
+          <p:cNvPr id="9" name="mermaid diagram" descr="96732578034c4f37.png"/>
           <p:cNvPicPr>
             <a:picLocks noChangeAspect="1"/>
           </p:cNvPicPr>
@@ -6979,8 +6984,8 @@
         </p:blipFill>
         <p:spPr>
           <a:xfrm>
-            <a:off x="780897" y="1956816"/>
-            <a:ext cx="10629900" cy="1600200"/>
+            <a:off x="580872" y="1956816"/>
+            <a:ext cx="11029950" cy="871537"/>
           </a:xfrm>
           <a:prstGeom prst="rect">
             <a:avLst/>
@@ -6995,7 +7000,7 @@
         </p:nvSpPr>
         <p:spPr>
           <a:xfrm>
-            <a:off x="530352" y="3703320"/>
+            <a:off x="530352" y="2974657"/>
             <a:ext cx="11130991" cy="772160"/>
           </a:xfrm>
           <a:prstGeom prst="rect">
@@ -10612,7 +10617,7 @@
       </p:sp>
       <p:pic>
         <p:nvPicPr>
-          <p:cNvPr id="9" name="mermaid diagram" descr="153b15e8f11f5824.png"/>
+          <p:cNvPr id="9" name="mermaid diagram" descr="741bb391915ef400.png"/>
           <p:cNvPicPr>
             <a:picLocks noChangeAspect="1"/>
           </p:cNvPicPr>
@@ -10626,8 +10631,8 @@
         </p:blipFill>
         <p:spPr>
           <a:xfrm>
-            <a:off x="3524097" y="1906714"/>
-            <a:ext cx="5143500" cy="3114675"/>
+            <a:off x="3188341" y="1956816"/>
+            <a:ext cx="5815012" cy="1800225"/>
           </a:xfrm>
           <a:prstGeom prst="rect">
             <a:avLst/>
@@ -10642,7 +10647,7 @@
         </p:nvSpPr>
         <p:spPr>
           <a:xfrm>
-            <a:off x="530352" y="5167693"/>
+            <a:off x="530352" y="3903345"/>
             <a:ext cx="11130991" cy="807720"/>
           </a:xfrm>
           <a:prstGeom prst="roundRect">
@@ -10690,7 +10695,7 @@
         </p:nvSpPr>
         <p:spPr>
           <a:xfrm>
-            <a:off x="676656" y="5295709"/>
+            <a:off x="676656" y="4031360"/>
             <a:ext cx="45720" cy="551688"/>
           </a:xfrm>
           <a:prstGeom prst="roundRect">
@@ -10736,7 +10741,7 @@
         </p:nvSpPr>
         <p:spPr>
           <a:xfrm>
-            <a:off x="877824" y="5286565"/>
+            <a:off x="877824" y="4022217"/>
             <a:ext cx="10564063" cy="624840"/>
           </a:xfrm>
           <a:prstGeom prst="rect">
@@ -13515,7 +13520,7 @@
       </p:sp>
       <p:pic>
         <p:nvPicPr>
-          <p:cNvPr id="9" name="mermaid diagram" descr="eec1c3cd32e674a1.png"/>
+          <p:cNvPr id="9" name="mermaid diagram" descr="2c9ff9ae5bedf1c3.png"/>
           <p:cNvPicPr>
             <a:picLocks noChangeAspect="1"/>
           </p:cNvPicPr>
@@ -13529,8 +13534,8 @@
         </p:blipFill>
         <p:spPr>
           <a:xfrm>
-            <a:off x="780897" y="1787461"/>
-            <a:ext cx="10629900" cy="3286125"/>
+            <a:off x="530352" y="1956816"/>
+            <a:ext cx="11130991" cy="1979765"/>
           </a:xfrm>
           <a:prstGeom prst="rect">
             <a:avLst/>
@@ -13545,20 +13550,25 @@
         </p:nvSpPr>
         <p:spPr>
           <a:xfrm>
-            <a:off x="530352" y="5242560"/>
-            <a:ext cx="11130991" cy="957072"/>
-          </a:xfrm>
-          <a:prstGeom prst="rect">
-            <a:avLst/>
-          </a:prstGeom>
-          <a:noFill/>
-        </p:spPr>
-        <p:txBody>
-          <a:bodyPr wrap="square" anchor="t" lIns="0" rIns="0" tIns="0" bIns="0">
-            <a:spAutoFit/>
-          </a:bodyPr>
-          <a:lstStyle/>
-          <a:p>
+            <a:off x="530352" y="4082885"/>
+            <a:ext cx="11130991" cy="1048512"/>
+          </a:xfrm>
+          <a:prstGeom prst="rect">
+            <a:avLst/>
+          </a:prstGeom>
+          <a:noFill/>
+        </p:spPr>
+        <p:txBody>
+          <a:bodyPr wrap="square" anchor="t" lIns="0" rIns="0" tIns="0" bIns="0">
+            <a:spAutoFit/>
+          </a:bodyPr>
+          <a:lstStyle/>
+          <a:p>
+            <a:pPr>
+              <a:spcAft>
+                <a:spcPts val="800"/>
+              </a:spcAft>
+            </a:pPr>
             <a:r>
               <a:rPr sz="1600" b="0" i="0">
                 <a:solidFill>
@@ -14183,7 +14193,7 @@
       </p:sp>
       <p:pic>
         <p:nvPicPr>
-          <p:cNvPr id="9" name="mermaid diagram" descr="56016b5bc7653e9e.png"/>
+          <p:cNvPr id="9" name="mermaid diagram" descr="61c759709507ab46.png"/>
           <p:cNvPicPr>
             <a:picLocks noChangeAspect="1"/>
           </p:cNvPicPr>
@@ -14197,8 +14207,8 @@
         </p:blipFill>
         <p:spPr>
           <a:xfrm>
-            <a:off x="1012032" y="1682496"/>
-            <a:ext cx="3822965" cy="4517136"/>
+            <a:off x="4135871" y="1664208"/>
+            <a:ext cx="3919952" cy="3250692"/>
           </a:xfrm>
           <a:prstGeom prst="rect">
             <a:avLst/>
@@ -14213,8 +14223,8 @@
         </p:nvSpPr>
         <p:spPr>
           <a:xfrm>
-            <a:off x="5761917" y="1956816"/>
-            <a:ext cx="5899425" cy="1607820"/>
+            <a:off x="530352" y="4960620"/>
+            <a:ext cx="11130991" cy="1074420"/>
           </a:xfrm>
           <a:prstGeom prst="roundRect">
             <a:avLst>
@@ -14261,8 +14271,8 @@
         </p:nvSpPr>
         <p:spPr>
           <a:xfrm>
-            <a:off x="5908221" y="2084832"/>
-            <a:ext cx="45720" cy="1351788"/>
+            <a:off x="676656" y="5088636"/>
+            <a:ext cx="45720" cy="818388"/>
           </a:xfrm>
           <a:prstGeom prst="roundRect">
             <a:avLst>
@@ -14307,8 +14317,8 @@
         </p:nvSpPr>
         <p:spPr>
           <a:xfrm>
-            <a:off x="6109389" y="2075688"/>
-            <a:ext cx="5332497" cy="1424940"/>
+            <a:off x="877824" y="5079492"/>
+            <a:ext cx="10564063" cy="891540"/>
           </a:xfrm>
           <a:prstGeom prst="rect">
             <a:avLst/>
@@ -18461,7 +18471,7 @@
                 </a:solidFill>
                 <a:latin typeface="Calibri"/>
               </a:rPr>
-              <a:t>Week 2 Tuesday: booked against collected</a:t>
+              <a:t>Week 2, Day 2. Can the collected number leave the team?</a:t>
             </a:r>
           </a:p>
         </p:txBody>
@@ -18737,7 +18747,7 @@
                 </a:solidFill>
                 <a:latin typeface="Calibri"/>
               </a:rPr>
-              <a:t>What does the escalated case ask, and which parts run before the faculty block?</a:t>
+              <a:t>What does the escalated case ask, and which parts run before the tentative faculty block?</a:t>
             </a:r>
           </a:p>
         </p:txBody>
@@ -21824,7 +21834,7 @@
         <p:spPr>
           <a:xfrm>
             <a:off x="731519" y="3520440"/>
-            <a:ext cx="9509760" cy="284226"/>
+            <a:ext cx="9509760" cy="531876"/>
           </a:xfrm>
           <a:prstGeom prst="rect">
             <a:avLst/>
@@ -21845,7 +21855,7 @@
                 </a:solidFill>
                 <a:latin typeface="Calibri"/>
               </a:rPr>
-              <a:t>Which parts of the day move to the TA-led practice lab and the take-home on a faculty day?</a:t>
+              <a:t>Which parts of the day move to the TA-led practice lab and the take-home, since the tentative faculty block takes the last 120 minutes?</a:t>
             </a:r>
           </a:p>
         </p:txBody>
@@ -22100,7 +22110,7 @@
                 </a:solidFill>
                 <a:latin typeface="Calibri"/>
               </a:rPr>
-              <a:t>Week 2 Tuesday: booked against collected</a:t>
+              <a:t>Week 2, Day 2. Can the collected number leave the team?</a:t>
             </a:r>
           </a:p>
         </p:txBody>
@@ -23945,39 +23955,15 @@
           </a:p>
         </p:txBody>
       </p:sp>
-      <p:pic>
-        <p:nvPicPr>
-          <p:cNvPr id="10" name="mermaid diagram" descr="4fb6ab9a231369f6.png"/>
-          <p:cNvPicPr>
-            <a:picLocks noChangeAspect="1"/>
-          </p:cNvPicPr>
-          <p:nvPr/>
-        </p:nvPicPr>
-        <p:blipFill>
-          <a:blip r:embed="rId6"/>
-          <a:stretch>
-            <a:fillRect/>
-          </a:stretch>
-        </p:blipFill>
-        <p:spPr>
-          <a:xfrm>
-            <a:off x="1910585" y="1664208"/>
-            <a:ext cx="8370525" cy="2295144"/>
-          </a:xfrm>
-          <a:prstGeom prst="rect">
-            <a:avLst/>
-          </a:prstGeom>
-        </p:spPr>
-      </p:pic>
-      <p:sp>
-        <p:nvSpPr>
-          <p:cNvPr id="11" name="Rounded Rectangle 10"/>
+      <p:sp>
+        <p:nvSpPr>
+          <p:cNvPr id="10" name="Rounded Rectangle 9"/>
           <p:cNvSpPr/>
           <p:nvPr/>
         </p:nvSpPr>
         <p:spPr>
           <a:xfrm>
-            <a:off x="530352" y="4005072"/>
+            <a:off x="530352" y="1809051"/>
             <a:ext cx="11130991" cy="1380744"/>
           </a:xfrm>
           <a:prstGeom prst="roundRect">
@@ -24031,13 +24017,13 @@
       </p:sp>
       <p:sp>
         <p:nvSpPr>
-          <p:cNvPr id="12" name="Oval 11"/>
+          <p:cNvPr id="11" name="Oval 10"/>
           <p:cNvSpPr/>
           <p:nvPr/>
         </p:nvSpPr>
         <p:spPr>
           <a:xfrm>
-            <a:off x="758952" y="4466844"/>
+            <a:off x="758952" y="2270823"/>
             <a:ext cx="457200" cy="457200"/>
           </a:xfrm>
           <a:prstGeom prst="ellipse">
@@ -24075,7 +24061,7 @@
       </p:sp>
       <p:pic>
         <p:nvPicPr>
-          <p:cNvPr id="13" name="Picture 12" descr="message-square_028dbd132a0a.png"/>
+          <p:cNvPr id="12" name="Picture 11" descr="message-square_028dbd132a0a.png"/>
           <p:cNvPicPr>
             <a:picLocks noChangeAspect="1"/>
           </p:cNvPicPr>
@@ -24089,7 +24075,7 @@
         </p:blipFill>
         <p:spPr>
           <a:xfrm>
-            <a:off x="868680" y="4576572"/>
+            <a:off x="868680" y="2380551"/>
             <a:ext cx="237744" cy="237744"/>
           </a:xfrm>
           <a:prstGeom prst="rect">
@@ -24099,48 +24085,48 @@
       </p:pic>
       <p:sp>
         <p:nvSpPr>
+          <p:cNvPr id="13" name="TextBox 12"/>
+          <p:cNvSpPr txBox="1"/>
+          <p:nvPr/>
+        </p:nvSpPr>
+        <p:spPr>
+          <a:xfrm>
+            <a:off x="1399031" y="1955355"/>
+            <a:ext cx="9987991" cy="160401"/>
+          </a:xfrm>
+          <a:prstGeom prst="rect">
+            <a:avLst/>
+          </a:prstGeom>
+          <a:noFill/>
+        </p:spPr>
+        <p:txBody>
+          <a:bodyPr wrap="square" anchor="t" lIns="0" rIns="0" tIns="0" bIns="0">
+            <a:spAutoFit/>
+          </a:bodyPr>
+          <a:lstStyle/>
+          <a:p>
+            <a:pPr algn="l"/>
+            <a:r>
+              <a:rPr sz="750" b="1" i="0" spc="250">
+                <a:solidFill>
+                  <a:srgbClr val="D9A7FF"/>
+                </a:solidFill>
+                <a:latin typeface="Calibri"/>
+              </a:rPr>
+              <a:t>THE CLIENT ASKS</a:t>
+            </a:r>
+          </a:p>
+        </p:txBody>
+      </p:sp>
+      <p:sp>
+        <p:nvSpPr>
           <p:cNvPr id="14" name="TextBox 13"/>
           <p:cNvSpPr txBox="1"/>
           <p:nvPr/>
         </p:nvSpPr>
         <p:spPr>
           <a:xfrm>
-            <a:off x="1399031" y="4151376"/>
-            <a:ext cx="9987991" cy="160401"/>
-          </a:xfrm>
-          <a:prstGeom prst="rect">
-            <a:avLst/>
-          </a:prstGeom>
-          <a:noFill/>
-        </p:spPr>
-        <p:txBody>
-          <a:bodyPr wrap="square" anchor="t" lIns="0" rIns="0" tIns="0" bIns="0">
-            <a:spAutoFit/>
-          </a:bodyPr>
-          <a:lstStyle/>
-          <a:p>
-            <a:pPr algn="l"/>
-            <a:r>
-              <a:rPr sz="750" b="1" i="0" spc="250">
-                <a:solidFill>
-                  <a:srgbClr val="D9A7FF"/>
-                </a:solidFill>
-                <a:latin typeface="Calibri"/>
-              </a:rPr>
-              <a:t>THE CLIENT ASKS</a:t>
-            </a:r>
-          </a:p>
-        </p:txBody>
-      </p:sp>
-      <p:sp>
-        <p:nvSpPr>
-          <p:cNvPr id="15" name="TextBox 14"/>
-          <p:cNvSpPr txBox="1"/>
-          <p:nvPr/>
-        </p:nvSpPr>
-        <p:spPr>
-          <a:xfrm>
-            <a:off x="1399031" y="4370832"/>
+            <a:off x="1399031" y="2174811"/>
             <a:ext cx="9987991" cy="941832"/>
           </a:xfrm>
           <a:prstGeom prst="rect">
@@ -24166,6 +24152,30 @@
           </a:p>
         </p:txBody>
       </p:sp>
+      <p:pic>
+        <p:nvPicPr>
+          <p:cNvPr id="15" name="mermaid diagram" descr="99fa2ec1c56e2489.png"/>
+          <p:cNvPicPr>
+            <a:picLocks noChangeAspect="1"/>
+          </p:cNvPicPr>
+          <p:nvPr/>
+        </p:nvPicPr>
+        <p:blipFill>
+          <a:blip r:embed="rId6"/>
+          <a:stretch>
+            <a:fillRect/>
+          </a:stretch>
+        </p:blipFill>
+        <p:spPr>
+          <a:xfrm>
+            <a:off x="1073791" y="3354387"/>
+            <a:ext cx="10044112" cy="1800225"/>
+          </a:xfrm>
+          <a:prstGeom prst="rect">
+            <a:avLst/>
+          </a:prstGeom>
+        </p:spPr>
+      </p:pic>
       <p:sp>
         <p:nvSpPr>
           <p:cNvPr id="16" name="TextBox 15"/>
@@ -24174,7 +24184,7 @@
         </p:nvSpPr>
         <p:spPr>
           <a:xfrm>
-            <a:off x="530352" y="5550408"/>
+            <a:off x="530352" y="5300916"/>
             <a:ext cx="11130991" cy="772160"/>
           </a:xfrm>
           <a:prstGeom prst="rect">
@@ -27111,7 +27121,7 @@
                 </a:solidFill>
                 <a:latin typeface="Calibri"/>
               </a:rPr>
-              <a:t>Week 2 Tuesday: booked against collected</a:t>
+              <a:t>Week 2, Day 2. Can the collected number leave the team?</a:t>
             </a:r>
           </a:p>
         </p:txBody>
@@ -27677,7 +27687,7 @@
                 </a:solidFill>
                 <a:latin typeface="Calibri"/>
               </a:rPr>
-              <a:t>Week 2 Tuesday: booked against collected</a:t>
+              <a:t>Week 2, Day 2. Can the collected number leave the team?</a:t>
             </a:r>
           </a:p>
         </p:txBody>
@@ -28040,7 +28050,7 @@
       </p:sp>
       <p:pic>
         <p:nvPicPr>
-          <p:cNvPr id="11" name="mermaid diagram" descr="c5f3ea3958ee9e95.png"/>
+          <p:cNvPr id="11" name="mermaid diagram" descr="e3f02b4a48641d12.png"/>
           <p:cNvPicPr>
             <a:picLocks noChangeAspect="1"/>
           </p:cNvPicPr>
@@ -28054,8 +28064,8 @@
         </p:blipFill>
         <p:spPr>
           <a:xfrm>
-            <a:off x="780897" y="3708400"/>
-            <a:ext cx="10629900" cy="1857375"/>
+            <a:off x="1088078" y="3708400"/>
+            <a:ext cx="10015537" cy="1128712"/>
           </a:xfrm>
           <a:prstGeom prst="rect">
             <a:avLst/>
@@ -29837,7 +29847,7 @@
                 </a:solidFill>
                 <a:latin typeface="Calibri"/>
               </a:rPr>
-              <a:t>then the faculty block</a:t>
+              <a:t>then the tentative faculty block</a:t>
             </a:r>
           </a:p>
         </p:txBody>
@@ -30525,7 +30535,7 @@
         </p:nvSpPr>
         <p:spPr>
           <a:xfrm>
-            <a:off x="530352" y="1798162"/>
+            <a:off x="530352" y="1956816"/>
             <a:ext cx="11130991" cy="1121664"/>
           </a:xfrm>
           <a:prstGeom prst="roundRect">
@@ -30585,7 +30595,7 @@
         </p:nvSpPr>
         <p:spPr>
           <a:xfrm>
-            <a:off x="758952" y="2130394"/>
+            <a:off x="758952" y="2289048"/>
             <a:ext cx="457200" cy="457200"/>
           </a:xfrm>
           <a:prstGeom prst="ellipse">
@@ -30637,7 +30647,7 @@
         </p:blipFill>
         <p:spPr>
           <a:xfrm>
-            <a:off x="868680" y="2240122"/>
+            <a:off x="868680" y="2398776"/>
             <a:ext cx="237744" cy="237744"/>
           </a:xfrm>
           <a:prstGeom prst="rect">
@@ -30653,7 +30663,7 @@
         </p:nvSpPr>
         <p:spPr>
           <a:xfrm>
-            <a:off x="1399031" y="1944466"/>
+            <a:off x="1399031" y="2103120"/>
             <a:ext cx="9987991" cy="160401"/>
           </a:xfrm>
           <a:prstGeom prst="rect">
@@ -30688,7 +30698,7 @@
         </p:nvSpPr>
         <p:spPr>
           <a:xfrm>
-            <a:off x="1399031" y="2163922"/>
+            <a:off x="1399031" y="2322576"/>
             <a:ext cx="9987991" cy="682752"/>
           </a:xfrm>
           <a:prstGeom prst="rect">
@@ -30716,7 +30726,7 @@
       </p:sp>
       <p:pic>
         <p:nvPicPr>
-          <p:cNvPr id="14" name="mermaid diagram" descr="805d941072fa487f.png"/>
+          <p:cNvPr id="14" name="mermaid diagram" descr="47cc74fe8fe61d19.png"/>
           <p:cNvPicPr>
             <a:picLocks noChangeAspect="1"/>
           </p:cNvPicPr>
@@ -30730,8 +30740,8 @@
         </p:blipFill>
         <p:spPr>
           <a:xfrm>
-            <a:off x="2152497" y="3084418"/>
-            <a:ext cx="7886700" cy="2357437"/>
+            <a:off x="1831028" y="3243072"/>
+            <a:ext cx="8529637" cy="1371600"/>
           </a:xfrm>
           <a:prstGeom prst="rect">
             <a:avLst/>
@@ -30746,7 +30756,7 @@
         </p:nvSpPr>
         <p:spPr>
           <a:xfrm>
-            <a:off x="530352" y="5588159"/>
+            <a:off x="530352" y="4760976"/>
             <a:ext cx="11130991" cy="495807"/>
           </a:xfrm>
           <a:prstGeom prst="rect">
@@ -37347,7 +37357,7 @@
       </p:sp>
       <p:pic>
         <p:nvPicPr>
-          <p:cNvPr id="9" name="mermaid diagram" descr="501c6bfed97e0e32.png"/>
+          <p:cNvPr id="9" name="mermaid diagram" descr="0bb799dff746d920.png"/>
           <p:cNvPicPr>
             <a:picLocks noChangeAspect="1"/>
           </p:cNvPicPr>
@@ -37361,8 +37371,8 @@
         </p:blipFill>
         <p:spPr>
           <a:xfrm>
-            <a:off x="1096358" y="1682496"/>
-            <a:ext cx="3654312" cy="4517136"/>
+            <a:off x="3447135" y="1664208"/>
+            <a:ext cx="5297424" cy="3250692"/>
           </a:xfrm>
           <a:prstGeom prst="rect">
             <a:avLst/>
@@ -37377,8 +37387,8 @@
         </p:nvSpPr>
         <p:spPr>
           <a:xfrm>
-            <a:off x="5761917" y="1956816"/>
-            <a:ext cx="5899425" cy="1607820"/>
+            <a:off x="530352" y="4960620"/>
+            <a:ext cx="11130991" cy="1074420"/>
           </a:xfrm>
           <a:prstGeom prst="roundRect">
             <a:avLst>
@@ -37425,8 +37435,8 @@
         </p:nvSpPr>
         <p:spPr>
           <a:xfrm>
-            <a:off x="5908221" y="2084832"/>
-            <a:ext cx="45720" cy="1351788"/>
+            <a:off x="676656" y="5088636"/>
+            <a:ext cx="45720" cy="818388"/>
           </a:xfrm>
           <a:prstGeom prst="roundRect">
             <a:avLst>
@@ -37471,8 +37481,8 @@
         </p:nvSpPr>
         <p:spPr>
           <a:xfrm>
-            <a:off x="6109389" y="2075688"/>
-            <a:ext cx="5332497" cy="1424940"/>
+            <a:off x="877824" y="5079492"/>
+            <a:ext cx="10564063" cy="891540"/>
           </a:xfrm>
           <a:prstGeom prst="rect">
             <a:avLst/>

</xml_diff>

<commit_message>
W02 D2: checkpoint of the humanizer's read of the exercises, solutions, take-home, extras and both builders; decks rebuilt
The read is still running on the builders, whose notebooks are rebuilt and executed when it finishes.
Every key letter is unchanged and the distractor audit passes on this state; both decks are rebuilt
from their current markdown.

Co-Authored-By: Claude Opus 5.5 <noreply@anthropic.com>
Claude-Session: https://claude.ai/code/session_012yAGwwKMxhSSXKbNHzQri6
</commit_message>
<xml_diff>
--- a/content/W02/D2/slides/C2_W02_D02_half2_STUDENT.pptx
+++ b/content/W02/D2/slides/C2_W02_D02_half2_STUDENT.pptx
@@ -1004,7 +1004,7 @@
           <a:lstStyle/>
           <a:p>
             <a:r>
-              <a:t>LIVE, 3 minutes. The fan-out row is the one to dwell on: a correct gap sitting on a wrong report.</a:t>
+              <a:t>LIVE, 2 minutes. The fan-out row is the one to dwell on: a correct gap sitting on a wrong report.</a:t>
             </a:r>
           </a:p>
           <a:p>
@@ -1079,7 +1079,7 @@
           <a:lstStyle/>
           <a:p>
             <a:r>
-              <a:t>LIVE, 2 minutes. The verdicts print; the figures that would name what the room is finding stay on</a:t>
+              <a:t>LIVE, 1 minute. The verdicts print; the figures that would name what the room is finding stay on</a:t>
             </a:r>
           </a:p>
           <a:p>
@@ -1154,7 +1154,7 @@
           <a:lstStyle/>
           <a:p>
             <a:r>
-              <a:t>LIVE, 3 minutes. The route shares no join, no GROUP BY and no NULL rule with the SQL report, so a</a:t>
+              <a:t>LIVE, 2 minutes. The route shares no join, no GROUP BY and no NULL rule with the SQL report, so a</a:t>
             </a:r>
           </a:p>
           <a:p>
@@ -1389,7 +1389,7 @@
           <a:lstStyle/>
           <a:p>
             <a:r>
-              <a:t>LIVE, 2 minutes. Read the five lines as the room's own findings; each learner's collected figure,</a:t>
+              <a:t>LIVE, 1 minute. Read the five lines as the room's own findings; each learner's collected figure,</a:t>
             </a:r>
           </a:p>
           <a:p>
@@ -1639,17 +1639,22 @@
           <a:lstStyle/>
           <a:p>
             <a:r>
-              <a:t>LIVE, 3 minutes. Read the five parts aloud, then start the clock. Each part's check tells a learner</a:t>
-            </a:r>
-          </a:p>
-          <a:p>
-            <a:r>
-              <a:t>whether their pick holds without showing the answer. Walk the room; the common stall in Part 2 is the</a:t>
-            </a:r>
-          </a:p>
-          <a:p>
-            <a:r>
-              <a:t>grain of the payments CTE.</a:t>
+              <a:t>LIVE, 3 minutes. Read the five parts aloud, show the next slide, then start the clock: 15 minutes</a:t>
+            </a:r>
+          </a:p>
+          <a:p>
+            <a:r>
+              <a:t>alone on parts 1 and 2, which with these two slides makes the block's 20. Each part's check tells a</a:t>
+            </a:r>
+          </a:p>
+          <a:p>
+            <a:r>
+              <a:t>learner whether their pick holds without showing the answer. Walk the room; the common stall in Part</a:t>
+            </a:r>
+          </a:p>
+          <a:p>
+            <a:r>
+              <a:t>2 is the grain of the payments CTE.</a:t>
             </a:r>
           </a:p>
         </p:txBody>
@@ -1719,17 +1724,17 @@
           <a:lstStyle/>
           <a:p>
             <a:r>
-              <a:t>LIVE, 2 minutes. The case is the day's chapters without the scaffolding. The debrief of wrong picks</a:t>
-            </a:r>
-          </a:p>
-          <a:p>
-            <a:r>
-              <a:t>runs in the practice lab, where the TA reads the most common wrong letters for each part.</a:t>
-            </a:r>
-          </a:p>
-          <a:p>
-            <a:r>
-              <a:t>Transition: what the lab and tonight carry.</a:t>
+              <a:t>LIVE, 2 minutes, before the clock starts. The case is the day's chapters without the scaffolding.</a:t>
+            </a:r>
+          </a:p>
+          <a:p>
+            <a:r>
+              <a:t>The debrief of wrong picks runs in the practice lab, where the TA reads the most common wrong letters</a:t>
+            </a:r>
+          </a:p>
+          <a:p>
+            <a:r>
+              <a:t>for each part. When the 15 minutes end, name the lab slides in one sentence and go to the close.</a:t>
             </a:r>
           </a:p>
         </p:txBody>
@@ -2034,7 +2039,67 @@
           </a:p>
           <a:p>
             <a:r>
-              <a:t>The full answers are in each chapter notebook's "In the interview" section and in the study notes.</a:t>
+              <a:t>Each answer in one breath, in the table's order. INNER keeps only matched rows; LEFT keeps every</a:t>
+            </a:r>
+          </a:p>
+          <a:p>
+            <a:r>
+              <a:t>left row with NULLs where nothing matched; both repeat a left row once per matching right row. A</a:t>
+            </a:r>
+          </a:p>
+          <a:p>
+            <a:r>
+              <a:t>row count grows when the join key repeats on the other table: count rows before and after, count that</a:t>
+            </a:r>
+          </a:p>
+          <a:p>
+            <a:r>
+              <a:t>table's rows per key, and bring it to the key's grain before the join. Orders with no payment come</a:t>
+            </a:r>
+          </a:p>
+          <a:p>
+            <a:r>
+              <a:t>from a LEFT JOIN that keeps the rows whose payment key IS NULL, or from NOT EXISTS, with the list's</a:t>
+            </a:r>
+          </a:p>
+          <a:p>
+            <a:r>
+              <a:t>booked total checked against its bar; never NOT IN, which returns nothing once the subquery holds a</a:t>
+            </a:r>
+          </a:p>
+          <a:p>
+            <a:r>
+              <a:t>NULL. When revenue doubles and every row looks fine, look at the grain: every row is real and the</a:t>
+            </a:r>
+          </a:p>
+          <a:p>
+            <a:r>
+              <a:t>sum runs per payment, so bring the many side to one row per order and recompute each table alone.</a:t>
+            </a:r>
+          </a:p>
+          <a:p>
+            <a:r>
+              <a:t>The validation design is counts, tie-backs to each table alone, one independent recomputation and a</a:t>
+            </a:r>
+          </a:p>
+          <a:p>
+            <a:r>
+              <a:t>test of the suite on known wrong reports; when a check fails late on reporting day, booked leaves</a:t>
+            </a:r>
+          </a:p>
+          <a:p>
+            <a:r>
+              <a:t>with the open line named and collected is held. An INNER join is honest when the unmatched rows are</a:t>
+            </a:r>
+          </a:p>
+          <a:p>
+            <a:r>
+              <a:t>outside the question by definition, such as days to the first payment for paid orders, and the</a:t>
+            </a:r>
+          </a:p>
+          <a:p>
+            <a:r>
+              <a:t>report says so.</a:t>
             </a:r>
           </a:p>
         </p:txBody>
@@ -2112,6 +2177,61 @@
               <a:t>switch. A strong answer names the check, the number it compares and the wrong report it stops.</a:t>
             </a:r>
           </a:p>
+          <a:p>
+            <a:r>
+              <a:t>Each answer in one breath, in the table's order. A condition on the right-hand table goes in ON; in</a:t>
+            </a:r>
+          </a:p>
+          <a:p>
+            <a:r>
+              <a:t>WHERE it runs after the join, drops the NULL rows and turns the LEFT JOIN into an INNER one.</a:t>
+            </a:r>
+          </a:p>
+          <a:p>
+            <a:r>
+              <a:t>HAVING COUNT(*) &gt; 1 by order finds every order with more than one payment row, legitimate</a:t>
+            </a:r>
+          </a:p>
+          <a:p>
+            <a:r>
+              <a:t>instalments included; a retry is one order and instalment posted twice. A joined total is reconciled</a:t>
+            </a:r>
+          </a:p>
+          <a:p>
+            <a:r>
+              <a:t>by recomputing it from the source table alone and naming every rupee of difference as a move with</a:t>
+            </a:r>
+          </a:p>
+          <a:p>
+            <a:r>
+              <a:t>its list. Two errors that cancel are found by counting first and then splitting the difference into</a:t>
+            </a:r>
+          </a:p>
+          <a:p>
+            <a:r>
+              <a:t>moves with definitions, so each error gets its own bar. A gap that looks too small is sized by</a:t>
+            </a:r>
+          </a:p>
+          <a:p>
+            <a:r>
+              <a:t>channel and by order, since a small total can be one large invoice, and by age, since an old unpaid</a:t>
+            </a:r>
+          </a:p>
+          <a:p>
+            <a:r>
+              <a:t>order is overdue; the cost of chasing is set against the cash, and the large, old orders go first.</a:t>
+            </a:r>
+          </a:p>
+          <a:p>
+            <a:r>
+              <a:t>The one check to keep is orders on the report against orders in the table: it reads no rupee and</a:t>
+            </a:r>
+          </a:p>
+          <a:p>
+            <a:r>
+              <a:t>catches a fan-out and a dropped order alike.</a:t>
+            </a:r>
+          </a:p>
         </p:txBody>
       </p:sp>
       <p:sp>
@@ -2254,17 +2374,22 @@
           <a:lstStyle/>
           <a:p>
             <a:r>
-              <a:t>LIVE. Chapter 6 runs 30 minutes: the map, the need and Wirecard (4), the four ways and the call (4),</a:t>
-            </a:r>
-          </a:p>
-          <a:p>
-            <a:r>
-              <a:t>the hurried checks and why they pass (6), the tie-back suite on one report and on all five (8),</a:t>
-            </a:r>
-          </a:p>
-          <a:p>
-            <a:r>
-              <a:t>Kalpa's report (2), the second route (3), the reporting-day rule (2), the close (1). Notebook 6,</a:t>
+              <a:t>LIVE. Chapter 6 runs 30 minutes with the cover and the morning's five answers (2): the map, the need</a:t>
+            </a:r>
+          </a:p>
+          <a:p>
+            <a:r>
+              <a:t>and Wirecard (4), the four ways and the call (4), the hurried checks and why they pass (6), the</a:t>
+            </a:r>
+          </a:p>
+          <a:p>
+            <a:r>
+              <a:t>tie-back suite on one report and on all five (7), Kalpa's report (1), the second route (2), the</a:t>
+            </a:r>
+          </a:p>
+          <a:p>
+            <a:r>
+              <a:t>reporting-day rule (3), the close (1). Notebook 6,</a:t>
             </a:r>
           </a:p>
           <a:p>
@@ -2339,7 +2464,7 @@
           <a:lstStyle/>
           <a:p>
             <a:r>
-              <a:t>LIVE, 2 minutes. Each learner fills the blanks from their own page; nobody reads another's figures</a:t>
+              <a:t>LIVE, 1 minute. Each learner fills the blanks from their own page; nobody reads another's figures</a:t>
             </a:r>
           </a:p>
           <a:p>
@@ -2419,7 +2544,7 @@
           <a:lstStyle/>
           <a:p>
             <a:r>
-              <a:t>LIVE, 2 minutes. These are the crux lines the cheat sheet prints word for word. Ask each learner to</a:t>
+              <a:t>LIVE, 1 minute. These are the crux lines the cheat sheet prints word for word. Ask each learner to</a:t>
             </a:r>
           </a:p>
           <a:p>
@@ -2804,7 +2929,7 @@
           </a:p>
           <a:p>
             <a:r>
-              <a:t>Irish Times on 26 June 2020, attributed to people with first-hand knowledge; all checked 30 Sep 2026,</a:t>
+              <a:t>Irish Times on 26 June 2020, attributed to people with first-hand knowledge; all checked 1 Oct 2026,</a:t>
             </a:r>
           </a:p>
           <a:p>
@@ -20506,7 +20631,7 @@
                 </a:solidFill>
                 <a:latin typeface="Georgia"/>
               </a:rPr>
-              <a:t>What the case asks that the chapters did not</a:t>
+              <a:t>Harder: Kalpa's data, your own picks and page</a:t>
             </a:r>
           </a:p>
         </p:txBody>
@@ -24767,7 +24892,7 @@
                 </a:solidFill>
                 <a:latin typeface="Georgia"/>
               </a:rPr>
-              <a:t>The interview drill: six questions every screen asks</a:t>
+              <a:t>The interview drill: six questions, aloud in pairs</a:t>
             </a:r>
           </a:p>
         </p:txBody>
@@ -31388,7 +31513,7 @@
         <p:spPr>
           <a:xfrm>
             <a:off x="530352" y="1956816"/>
-            <a:ext cx="11130991" cy="1074420"/>
+            <a:ext cx="11130991" cy="1341120"/>
           </a:xfrm>
           <a:prstGeom prst="roundRect">
             <a:avLst>
@@ -31436,7 +31561,7 @@
         <p:spPr>
           <a:xfrm>
             <a:off x="676656" y="2084832"/>
-            <a:ext cx="45720" cy="818388"/>
+            <a:ext cx="45720" cy="1085088"/>
           </a:xfrm>
           <a:prstGeom prst="roundRect">
             <a:avLst>
@@ -31482,7 +31607,7 @@
         <p:spPr>
           <a:xfrm>
             <a:off x="877824" y="2075688"/>
-            <a:ext cx="10564063" cy="891540"/>
+            <a:ext cx="10564063" cy="1158240"/>
           </a:xfrm>
           <a:prstGeom prst="rect">
             <a:avLst/>
@@ -31511,7 +31636,7 @@
                 </a:solidFill>
                 <a:latin typeface="Calibri"/>
               </a:rPr>
-              <a:t>Kavya, who reviews every number before it leaves the team; Anand, who forwards it to the CEO's Monday page; and you, who sign it. A validation that cannot fail puts a PASS stamp on a wrong number, and a stamped wrong number is harder to withdraw than an unstamped one.</a:t>
+              <a:t>Kavya Nair, the team's senior analyst, who reviews every number before it leaves the team; Anand, who forwards it to the CEO's Monday page; and you, who sign it. A validation that cannot fail puts a PASS stamp on a wrong number, and a stamped wrong number is harder to withdraw than an unstamped one.</a:t>
             </a:r>
           </a:p>
         </p:txBody>
@@ -31524,7 +31649,7 @@
         </p:nvSpPr>
         <p:spPr>
           <a:xfrm>
-            <a:off x="1381734" y="3762756"/>
+            <a:off x="1381734" y="4029456"/>
             <a:ext cx="9428226" cy="18288"/>
           </a:xfrm>
           <a:prstGeom prst="rect">
@@ -31568,7 +31693,7 @@
         </p:nvSpPr>
         <p:spPr>
           <a:xfrm>
-            <a:off x="530352" y="3195828"/>
+            <a:off x="530352" y="3462528"/>
             <a:ext cx="1702765" cy="168656"/>
           </a:xfrm>
           <a:prstGeom prst="rect">
@@ -31603,7 +31728,7 @@
         </p:nvSpPr>
         <p:spPr>
           <a:xfrm>
-            <a:off x="1281150" y="3671316"/>
+            <a:off x="1281150" y="3938016"/>
             <a:ext cx="201168" cy="201168"/>
           </a:xfrm>
           <a:prstGeom prst="ellipse">
@@ -31647,7 +31772,7 @@
         </p:nvSpPr>
         <p:spPr>
           <a:xfrm>
-            <a:off x="530352" y="4082796"/>
+            <a:off x="530352" y="4349496"/>
             <a:ext cx="1702765" cy="1249680"/>
           </a:xfrm>
           <a:prstGeom prst="roundRect">
@@ -31701,7 +31826,7 @@
         </p:nvSpPr>
         <p:spPr>
           <a:xfrm>
-            <a:off x="694944" y="4229100"/>
+            <a:off x="694944" y="4495800"/>
             <a:ext cx="1373581" cy="251205"/>
           </a:xfrm>
           <a:prstGeom prst="rect">
@@ -31736,7 +31861,7 @@
         </p:nvSpPr>
         <p:spPr>
           <a:xfrm>
-            <a:off x="694944" y="4516882"/>
+            <a:off x="694944" y="4783582"/>
             <a:ext cx="1373581" cy="531876"/>
           </a:xfrm>
           <a:prstGeom prst="rect">
@@ -31771,7 +31896,7 @@
         </p:nvSpPr>
         <p:spPr>
           <a:xfrm>
-            <a:off x="2415997" y="3195828"/>
+            <a:off x="2415997" y="3462528"/>
             <a:ext cx="1702765" cy="168656"/>
           </a:xfrm>
           <a:prstGeom prst="rect">
@@ -31806,7 +31931,7 @@
         </p:nvSpPr>
         <p:spPr>
           <a:xfrm>
-            <a:off x="3166795" y="3671316"/>
+            <a:off x="3166795" y="3938016"/>
             <a:ext cx="201168" cy="201168"/>
           </a:xfrm>
           <a:prstGeom prst="ellipse">
@@ -31850,7 +31975,7 @@
         </p:nvSpPr>
         <p:spPr>
           <a:xfrm>
-            <a:off x="2415997" y="4082796"/>
+            <a:off x="2415997" y="4349496"/>
             <a:ext cx="1702765" cy="1249680"/>
           </a:xfrm>
           <a:prstGeom prst="roundRect">
@@ -31904,7 +32029,7 @@
         </p:nvSpPr>
         <p:spPr>
           <a:xfrm>
-            <a:off x="2580589" y="4229100"/>
+            <a:off x="2580589" y="4495800"/>
             <a:ext cx="1373581" cy="251205"/>
           </a:xfrm>
           <a:prstGeom prst="rect">
@@ -31939,7 +32064,7 @@
         </p:nvSpPr>
         <p:spPr>
           <a:xfrm>
-            <a:off x="2580589" y="4516882"/>
+            <a:off x="2580589" y="4783582"/>
             <a:ext cx="1373581" cy="366776"/>
           </a:xfrm>
           <a:prstGeom prst="rect">
@@ -31974,7 +32099,7 @@
         </p:nvSpPr>
         <p:spPr>
           <a:xfrm>
-            <a:off x="4301642" y="3195828"/>
+            <a:off x="4301642" y="3462528"/>
             <a:ext cx="1702765" cy="168656"/>
           </a:xfrm>
           <a:prstGeom prst="rect">
@@ -32009,7 +32134,7 @@
         </p:nvSpPr>
         <p:spPr>
           <a:xfrm>
-            <a:off x="5052441" y="3671316"/>
+            <a:off x="5052441" y="3938016"/>
             <a:ext cx="201168" cy="201168"/>
           </a:xfrm>
           <a:prstGeom prst="ellipse">
@@ -32053,7 +32178,7 @@
         </p:nvSpPr>
         <p:spPr>
           <a:xfrm>
-            <a:off x="4301642" y="4082796"/>
+            <a:off x="4301642" y="4349496"/>
             <a:ext cx="1702765" cy="1249680"/>
           </a:xfrm>
           <a:prstGeom prst="roundRect">
@@ -32107,7 +32232,7 @@
         </p:nvSpPr>
         <p:spPr>
           <a:xfrm>
-            <a:off x="4466234" y="4229100"/>
+            <a:off x="4466234" y="4495800"/>
             <a:ext cx="1373581" cy="251205"/>
           </a:xfrm>
           <a:prstGeom prst="rect">
@@ -32142,7 +32267,7 @@
         </p:nvSpPr>
         <p:spPr>
           <a:xfrm>
-            <a:off x="4466234" y="4516882"/>
+            <a:off x="4466234" y="4783582"/>
             <a:ext cx="1373581" cy="531876"/>
           </a:xfrm>
           <a:prstGeom prst="rect">
@@ -32177,7 +32302,7 @@
         </p:nvSpPr>
         <p:spPr>
           <a:xfrm>
-            <a:off x="6187287" y="3195828"/>
+            <a:off x="6187287" y="3462528"/>
             <a:ext cx="1702765" cy="168656"/>
           </a:xfrm>
           <a:prstGeom prst="rect">
@@ -32212,7 +32337,7 @@
         </p:nvSpPr>
         <p:spPr>
           <a:xfrm>
-            <a:off x="6938086" y="3671316"/>
+            <a:off x="6938086" y="3938016"/>
             <a:ext cx="201168" cy="201168"/>
           </a:xfrm>
           <a:prstGeom prst="ellipse">
@@ -32256,7 +32381,7 @@
         </p:nvSpPr>
         <p:spPr>
           <a:xfrm>
-            <a:off x="6187287" y="4082796"/>
+            <a:off x="6187287" y="4349496"/>
             <a:ext cx="1702765" cy="1249680"/>
           </a:xfrm>
           <a:prstGeom prst="roundRect">
@@ -32310,7 +32435,7 @@
         </p:nvSpPr>
         <p:spPr>
           <a:xfrm>
-            <a:off x="6351879" y="4229100"/>
+            <a:off x="6351879" y="4495800"/>
             <a:ext cx="1373581" cy="251205"/>
           </a:xfrm>
           <a:prstGeom prst="rect">
@@ -32345,7 +32470,7 @@
         </p:nvSpPr>
         <p:spPr>
           <a:xfrm>
-            <a:off x="6351879" y="4516882"/>
+            <a:off x="6351879" y="4783582"/>
             <a:ext cx="1373581" cy="366776"/>
           </a:xfrm>
           <a:prstGeom prst="rect">
@@ -32380,7 +32505,7 @@
         </p:nvSpPr>
         <p:spPr>
           <a:xfrm>
-            <a:off x="8072932" y="3195828"/>
+            <a:off x="8072932" y="3462528"/>
             <a:ext cx="1702765" cy="168656"/>
           </a:xfrm>
           <a:prstGeom prst="rect">
@@ -32415,7 +32540,7 @@
         </p:nvSpPr>
         <p:spPr>
           <a:xfrm>
-            <a:off x="8823731" y="3671316"/>
+            <a:off x="8823731" y="3938016"/>
             <a:ext cx="201168" cy="201168"/>
           </a:xfrm>
           <a:prstGeom prst="ellipse">
@@ -32459,7 +32584,7 @@
         </p:nvSpPr>
         <p:spPr>
           <a:xfrm>
-            <a:off x="8072932" y="4082796"/>
+            <a:off x="8072932" y="4349496"/>
             <a:ext cx="1702765" cy="1249680"/>
           </a:xfrm>
           <a:prstGeom prst="roundRect">
@@ -32513,7 +32638,7 @@
         </p:nvSpPr>
         <p:spPr>
           <a:xfrm>
-            <a:off x="8237524" y="4229100"/>
+            <a:off x="8237524" y="4495800"/>
             <a:ext cx="1373581" cy="251205"/>
           </a:xfrm>
           <a:prstGeom prst="rect">
@@ -32548,7 +32673,7 @@
         </p:nvSpPr>
         <p:spPr>
           <a:xfrm>
-            <a:off x="8237524" y="4516882"/>
+            <a:off x="8237524" y="4783582"/>
             <a:ext cx="1373581" cy="366776"/>
           </a:xfrm>
           <a:prstGeom prst="rect">
@@ -32583,7 +32708,7 @@
         </p:nvSpPr>
         <p:spPr>
           <a:xfrm>
-            <a:off x="9958578" y="3195828"/>
+            <a:off x="9958578" y="3462528"/>
             <a:ext cx="1702765" cy="168656"/>
           </a:xfrm>
           <a:prstGeom prst="rect">
@@ -32618,7 +32743,7 @@
         </p:nvSpPr>
         <p:spPr>
           <a:xfrm>
-            <a:off x="10709376" y="3671316"/>
+            <a:off x="10709376" y="3938016"/>
             <a:ext cx="201168" cy="201168"/>
           </a:xfrm>
           <a:prstGeom prst="ellipse">
@@ -32662,7 +32787,7 @@
         </p:nvSpPr>
         <p:spPr>
           <a:xfrm>
-            <a:off x="9958578" y="4082796"/>
+            <a:off x="9958578" y="4349496"/>
             <a:ext cx="1702765" cy="1249680"/>
           </a:xfrm>
           <a:prstGeom prst="roundRect">
@@ -32722,7 +32847,7 @@
         </p:nvSpPr>
         <p:spPr>
           <a:xfrm>
-            <a:off x="10123170" y="4229100"/>
+            <a:off x="10123170" y="4495800"/>
             <a:ext cx="1373581" cy="251205"/>
           </a:xfrm>
           <a:prstGeom prst="rect">
@@ -32757,7 +32882,7 @@
         </p:nvSpPr>
         <p:spPr>
           <a:xfrm>
-            <a:off x="10123170" y="4516882"/>
+            <a:off x="10123170" y="4783582"/>
             <a:ext cx="1373581" cy="531876"/>
           </a:xfrm>
           <a:prstGeom prst="rect">
@@ -35551,7 +35676,7 @@
                 </a:solidFill>
                 <a:latin typeface="Calibri"/>
               </a:rPr>
-              <a:t>A check that reads a company's own records back to it cannot fail.</a:t>
+              <a:t>A check built only on documents the company supplies can confirm only what the company says.</a:t>
             </a:r>
           </a:p>
         </p:txBody>

</xml_diff>

<commit_message>
W02 D2: the tie-back suite is described as read outside the report, since the gap's check uses the two lists; the afternoon deck rebuilt
Co-Authored-By: Claude Opus 5.5 <noreply@anthropic.com>
Claude-Session: https://claude.ai/code/session_012yAGwwKMxhSSXKbNHzQri6
</commit_message>
<xml_diff>
--- a/content/W02/D2/slides/C2_W02_D02_half2_STUDENT.pptx
+++ b/content/W02/D2/slides/C2_W02_D02_half2_STUDENT.pptx
@@ -850,7 +850,7 @@
           <a:lstStyle/>
           <a:p>
             <a:r>
-              <a:t>LIVE, 2 minutes. Each tie-back check recomputes one figure from a single table and compares it with</a:t>
+              <a:t>LIVE, 2 minutes. Each tie-back check recomputes one figure outside the report and compares it with</a:t>
             </a:r>
           </a:p>
           <a:p>
@@ -2050,17 +2050,12 @@
           <a:lstStyle/>
           <a:p>
             <a:r>
-              <a:t>SELF-STUDY, 40 minutes in the lab. This question starts from payments, because it is about every row</a:t>
-            </a:r>
-          </a:p>
-          <a:p>
-            <a:r>
-              <a:t>the feed holds, which is the fact chapter 1 said would change the join. A retry is the same order and</a:t>
-            </a:r>
-          </a:p>
-          <a:p>
-            <a:r>
-              <a:t>instalment posted twice; the platform lead fixes the feed, so the audit covers both quarters.</a:t>
+              <a:t>SELF-STUDY, 40 minutes in the lab. The pairs post their four letters and the request; the TA reads</a:t>
+            </a:r>
+          </a:p>
+          <a:p>
+            <a:r>
+              <a:t>the most common wrong letter for each part, and the reasons are in the case's solution page.</a:t>
             </a:r>
           </a:p>
         </p:txBody>
@@ -3280,7 +3275,12 @@
           </a:p>
           <a:p>
             <a:r>
-              <a:t>from one table alone, where no join can multiply or drop anything. The Python recomputation reaches</a:t>
+              <a:t>outside it: booked from orders alone, posted from payments alone, and the gap from lists no join can</a:t>
+            </a:r>
+          </a:p>
+          <a:p>
+            <a:r>
+              <a:t>multiply. The Python recomputation reaches</a:t>
             </a:r>
           </a:p>
           <a:p>
@@ -19377,7 +19377,7 @@
                           </a:solidFill>
                           <a:latin typeface="Calibri"/>
                         </a:rPr>
-                        <a:t>Five checks recompute orders, booked, the gap and posted from one table each</a:t>
+                        <a:t>Five checks recompute orders, booked, the gap and posted outside the page</a:t>
                       </a:r>
                     </a:p>
                   </a:txBody>
@@ -25255,7 +25255,7 @@
                 </a:solidFill>
                 <a:latin typeface="Calibri"/>
               </a:rPr>
-              <a:t>The platform lead's audit of the feed, both quarters, four parts.</a:t>
+              <a:t>The platform lead's audit of the payments feed, in four parts.</a:t>
             </a:r>
           </a:p>
         </p:txBody>
@@ -26321,7 +26321,7 @@
       </p:sp>
       <p:pic>
         <p:nvPicPr>
-          <p:cNvPr id="10" name="mermaid diagram" descr="99fa2ec1c56e2489.png"/>
+          <p:cNvPr id="10" name="mermaid diagram" descr="8a735fc47f5122e5.png"/>
           <p:cNvPicPr>
             <a:picLocks noChangeAspect="1"/>
           </p:cNvPicPr>
@@ -26335,8 +26335,8 @@
         </p:blipFill>
         <p:spPr>
           <a:xfrm>
-            <a:off x="1073791" y="1911667"/>
-            <a:ext cx="10044112" cy="1800225"/>
+            <a:off x="1380972" y="1911667"/>
+            <a:ext cx="9429750" cy="1800225"/>
           </a:xfrm>
           <a:prstGeom prst="rect">
             <a:avLst/>
@@ -26535,7 +26535,7 @@
                 </a:solidFill>
                 <a:latin typeface="Calibri"/>
               </a:rPr>
-              <a:t>"Before I repair the payments feed, tell me which rows in it should not be there: payments with no order behind them, and payments the gateway posted twice. Both quarters, with the dates, the methods and the rupees at stake, and tell me what to fix first." The data platform lead, Kalpa Retail</a:t>
+              <a:t>"Before I repair the payments feed, tell me which rows in it should not be there: payments with no order behind them, and payments the gateway posted twice, with the dates, the methods and the rupees at stake, and tell me what to fix first." The data platform lead, Kalpa Retail</a:t>
             </a:r>
           </a:p>
         </p:txBody>
@@ -26574,7 +26574,7 @@
                 </a:solidFill>
                 <a:latin typeface="Calibri"/>
               </a:rPr>
-              <a:t>In pairs in the lab, four parts: is every payment row in the feed accounted for; which payments match no order; which instalments were posted more than once, in either quarter; and is there a pattern the gateway team can act on. The notebook is notebooks/C2_W02_D02_ex2_second_case_STUDENT.ipynb.</a:t>
+              <a:t>In pairs in the lab, four parts: is every payment row in the feed accounted for; which payments match no order; which instalments did the feed post more than once; and is there a pattern the gateway team can act on. The notebook is notebooks/C2_W02_D02_ex2_second_case_STUDENT.ipynb.</a:t>
             </a:r>
           </a:p>
         </p:txBody>
@@ -34980,7 +34980,7 @@
                 </a:solidFill>
                 <a:latin typeface="Calibri"/>
               </a:rPr>
-              <a:t>Five checks, each read from one table alone.</a:t>
+              <a:t>Five checks, each read outside the report.</a:t>
             </a:r>
           </a:p>
         </p:txBody>
@@ -39457,7 +39457,7 @@
                           </a:solidFill>
                           <a:latin typeface="Calibri"/>
                         </a:rPr>
-                        <a:t>Every figure recomputed from one table alone and compared</a:t>
+                        <a:t>Every figure recomputed from the source tables and compared</a:t>
                       </a:r>
                     </a:p>
                   </a:txBody>

</xml_diff>